<commit_message>
Unify lecture covers with concept figures and both affiliations
</commit_message>
<xml_diff>
--- a/03_タンパク質構造の基礎/03_タンパク質構造の基礎.pptx
+++ b/03_タンパク質構造の基礎/03_タンパク質構造の基礎.pptx
@@ -6283,8 +6283,279 @@
         </p:nvSpPr>
         <p:spPr>
           <a:xfrm>
-            <a:off x="594360" y="914400"/>
-            <a:ext cx="6400800" cy="365760"/>
+            <a:off x="822960" y="1417320"/>
+            <a:ext cx="5852160" cy="329184"/>
+          </a:xfrm>
+          <a:prstGeom prst="rect">
+            <a:avLst/>
+          </a:prstGeom>
+          <a:noFill/>
+        </p:spPr>
+        <p:txBody>
+          <a:bodyPr wrap="square" lIns="0" rIns="0" tIns="0" bIns="0" anchor="t">
+            <a:noAutofit/>
+          </a:bodyPr>
+          <a:lstStyle/>
+          <a:p>
+            <a:pPr algn="l">
+              <a:lnSpc>
+                <a:spcPts val="1680"/>
+              </a:lnSpc>
+            </a:pPr>
+            <a:r>
+              <a:rPr sz="1400" b="1" lang="ja-JP" altLang="en-US">
+                <a:solidFill>
+                  <a:srgbClr val="0017C1"/>
+                </a:solidFill>
+                <a:latin typeface="Noto Sans JP"/>
+                <a:ea typeface="Noto Sans JP"/>
+              </a:rPr>
+              <a:t>生命情報工学特論　第03回</a:t>
+            </a:r>
+          </a:p>
+        </p:txBody>
+      </p:sp>
+      <p:sp>
+        <p:nvSpPr>
+          <p:cNvPr id="3" name="TextBox 2"/>
+          <p:cNvSpPr txBox="1"/>
+          <p:nvPr/>
+        </p:nvSpPr>
+        <p:spPr>
+          <a:xfrm>
+            <a:off x="822960" y="1828800"/>
+            <a:ext cx="5852160" cy="1188720"/>
+          </a:xfrm>
+          <a:prstGeom prst="rect">
+            <a:avLst/>
+          </a:prstGeom>
+          <a:noFill/>
+        </p:spPr>
+        <p:txBody>
+          <a:bodyPr wrap="square" lIns="0" rIns="0" tIns="0" bIns="0" anchor="t">
+            <a:noAutofit/>
+          </a:bodyPr>
+          <a:lstStyle/>
+          <a:p>
+            <a:pPr algn="l">
+              <a:lnSpc>
+                <a:spcPts val="4200"/>
+              </a:lnSpc>
+            </a:pPr>
+            <a:r>
+              <a:rPr sz="3400" b="1" lang="ja-JP" altLang="en-US">
+                <a:solidFill>
+                  <a:srgbClr val="1A1A1A"/>
+                </a:solidFill>
+                <a:latin typeface="Noto Sans JP"/>
+                <a:ea typeface="Noto Sans JP"/>
+              </a:rPr>
+              <a:t>タンパク質構造の
+基礎</a:t>
+            </a:r>
+          </a:p>
+        </p:txBody>
+      </p:sp>
+      <p:sp>
+        <p:nvSpPr>
+          <p:cNvPr id="4" name="TextBox 3"/>
+          <p:cNvSpPr txBox="1"/>
+          <p:nvPr/>
+        </p:nvSpPr>
+        <p:spPr>
+          <a:xfrm>
+            <a:off x="822960" y="3273552"/>
+            <a:ext cx="5669280" cy="1280160"/>
+          </a:xfrm>
+          <a:prstGeom prst="rect">
+            <a:avLst/>
+          </a:prstGeom>
+          <a:noFill/>
+        </p:spPr>
+        <p:txBody>
+          <a:bodyPr wrap="square" lIns="0" rIns="0" tIns="0" bIns="0" anchor="t">
+            <a:noAutofit/>
+          </a:bodyPr>
+          <a:lstStyle/>
+          <a:p>
+            <a:pPr algn="l">
+              <a:lnSpc>
+                <a:spcPts val="2790"/>
+              </a:lnSpc>
+            </a:pPr>
+            <a:r>
+              <a:rPr sz="1800" b="0" lang="ja-JP" altLang="en-US">
+                <a:solidFill>
+                  <a:srgbClr val="4D4D4D"/>
+                </a:solidFill>
+                <a:latin typeface="Noto Sans JP"/>
+                <a:ea typeface="Noto Sans JP"/>
+              </a:rPr>
+              <a:t>配列・相互作用・立体構造</a:t>
+            </a:r>
+          </a:p>
+          <a:p>
+            <a:pPr algn="l">
+              <a:lnSpc>
+                <a:spcPts val="2790"/>
+              </a:lnSpc>
+            </a:pPr>
+            <a:r>
+              <a:rPr sz="1800" b="0" lang="ja-JP" altLang="en-US">
+                <a:solidFill>
+                  <a:srgbClr val="4D4D4D"/>
+                </a:solidFill>
+                <a:latin typeface="Noto Sans JP"/>
+                <a:ea typeface="Noto Sans JP"/>
+              </a:rPr>
+              <a:t/>
+            </a:r>
+          </a:p>
+        </p:txBody>
+      </p:sp>
+      <p:cxnSp>
+        <p:nvCxnSpPr>
+          <p:cNvPr id="5" name="Connector 4"/>
+          <p:cNvCxnSpPr/>
+          <p:nvPr/>
+        </p:nvCxnSpPr>
+        <p:spPr>
+          <a:xfrm>
+            <a:off x="822960" y="4892040"/>
+            <a:ext cx="5212080" cy="0"/>
+          </a:xfrm>
+          <a:prstGeom prst="line">
+            <a:avLst/>
+          </a:prstGeom>
+          <a:ln w="12700">
+            <a:solidFill>
+              <a:srgbClr val="CCCCCC"/>
+            </a:solidFill>
+          </a:ln>
+        </p:spPr>
+        <p:style>
+          <a:lnRef idx="2">
+            <a:schemeClr val="accent1"/>
+          </a:lnRef>
+          <a:fillRef idx="0">
+            <a:schemeClr val="accent1"/>
+          </a:fillRef>
+          <a:effectRef idx="1">
+            <a:schemeClr val="accent1"/>
+          </a:effectRef>
+          <a:fontRef idx="minor">
+            <a:schemeClr val="tx1"/>
+          </a:fontRef>
+        </p:style>
+      </p:cxnSp>
+      <p:sp>
+        <p:nvSpPr>
+          <p:cNvPr id="6" name="TextBox 5"/>
+          <p:cNvSpPr txBox="1"/>
+          <p:nvPr/>
+        </p:nvSpPr>
+        <p:spPr>
+          <a:xfrm>
+            <a:off x="822960" y="5029200"/>
+            <a:ext cx="5486400" cy="320040"/>
+          </a:xfrm>
+          <a:prstGeom prst="rect">
+            <a:avLst/>
+          </a:prstGeom>
+          <a:noFill/>
+        </p:spPr>
+        <p:txBody>
+          <a:bodyPr wrap="square" lIns="0" rIns="0" tIns="0" bIns="0" anchor="t">
+            <a:noAutofit/>
+          </a:bodyPr>
+          <a:lstStyle/>
+          <a:p>
+            <a:pPr algn="l">
+              <a:lnSpc>
+                <a:spcPts val="1920"/>
+              </a:lnSpc>
+            </a:pPr>
+            <a:r>
+              <a:rPr sz="1600" b="1" lang="ja-JP" altLang="en-US">
+                <a:solidFill>
+                  <a:srgbClr val="1A1A1A"/>
+                </a:solidFill>
+                <a:latin typeface="Noto Sans JP"/>
+                <a:ea typeface="Noto Sans JP"/>
+              </a:rPr>
+              <a:t>松永 康佑</a:t>
+            </a:r>
+          </a:p>
+        </p:txBody>
+      </p:sp>
+      <p:sp>
+        <p:nvSpPr>
+          <p:cNvPr id="7" name="TextBox 6"/>
+          <p:cNvSpPr txBox="1"/>
+          <p:nvPr/>
+        </p:nvSpPr>
+        <p:spPr>
+          <a:xfrm>
+            <a:off x="822960" y="5394960"/>
+            <a:ext cx="5486400" cy="548640"/>
+          </a:xfrm>
+          <a:prstGeom prst="rect">
+            <a:avLst/>
+          </a:prstGeom>
+          <a:noFill/>
+        </p:spPr>
+        <p:txBody>
+          <a:bodyPr wrap="square" lIns="0" rIns="0" tIns="0" bIns="0" anchor="t">
+            <a:noAutofit/>
+          </a:bodyPr>
+          <a:lstStyle/>
+          <a:p>
+            <a:pPr algn="l">
+              <a:lnSpc>
+                <a:spcPts val="1439"/>
+              </a:lnSpc>
+            </a:pPr>
+            <a:r>
+              <a:rPr sz="1200" b="0" lang="ja-JP" altLang="en-US">
+                <a:solidFill>
+                  <a:srgbClr val="666666"/>
+                </a:solidFill>
+                <a:latin typeface="Noto Sans JP"/>
+                <a:ea typeface="Noto Sans JP"/>
+              </a:rPr>
+              <a:t>埼玉大学 大学院理工学研究科
+理化学研究所 計算科学研究センター ｜ 2026年10月19日</a:t>
+            </a:r>
+          </a:p>
+          <a:p>
+            <a:pPr algn="l">
+              <a:lnSpc>
+                <a:spcPts val="1439"/>
+              </a:lnSpc>
+            </a:pPr>
+            <a:r>
+              <a:rPr sz="1200" b="0" lang="ja-JP" altLang="en-US">
+                <a:solidFill>
+                  <a:srgbClr val="666666"/>
+                </a:solidFill>
+                <a:latin typeface="Noto Sans JP"/>
+                <a:ea typeface="Noto Sans JP"/>
+              </a:rPr>
+              <a:t/>
+            </a:r>
+          </a:p>
+        </p:txBody>
+      </p:sp>
+      <p:sp>
+        <p:nvSpPr>
+          <p:cNvPr id="8" name="TextBox 7"/>
+          <p:cNvSpPr txBox="1"/>
+          <p:nvPr/>
+        </p:nvSpPr>
+        <p:spPr>
+          <a:xfrm>
+            <a:off x="6537960" y="6236208"/>
+            <a:ext cx="5212080" cy="320040"/>
           </a:xfrm>
           <a:prstGeom prst="rect">
             <a:avLst/>
@@ -6303,181 +6574,37 @@
               </a:lnSpc>
             </a:pPr>
             <a:r>
-              <a:rPr sz="2000" b="1" lang="ja-JP" altLang="en-US">
-                <a:solidFill>
-                  <a:srgbClr val="0017C1"/>
-                </a:solidFill>
-                <a:latin typeface="Noto Sans JP"/>
-                <a:ea typeface="Noto Sans JP"/>
-              </a:rPr>
-              <a:t>生命情報工学特論 第03回</a:t>
-            </a:r>
-          </a:p>
-        </p:txBody>
-      </p:sp>
-      <p:sp>
-        <p:nvSpPr>
-          <p:cNvPr id="3" name="TextBox 2"/>
-          <p:cNvSpPr txBox="1"/>
-          <p:nvPr/>
-        </p:nvSpPr>
-        <p:spPr>
-          <a:xfrm>
-            <a:off x="594360" y="1828800"/>
-            <a:ext cx="7315200" cy="822960"/>
-          </a:xfrm>
-          <a:prstGeom prst="rect">
-            <a:avLst/>
-          </a:prstGeom>
-          <a:noFill/>
-        </p:spPr>
-        <p:txBody>
-          <a:bodyPr wrap="square" lIns="0" rIns="0" tIns="0" bIns="0" anchor="t">
-            <a:noAutofit/>
-          </a:bodyPr>
-          <a:lstStyle/>
-          <a:p>
-            <a:pPr algn="l">
-              <a:lnSpc>
-                <a:spcPct val="140000"/>
-              </a:lnSpc>
-            </a:pPr>
-            <a:r>
-              <a:rPr sz="3600" b="1" lang="ja-JP" altLang="en-US">
-                <a:solidFill>
-                  <a:srgbClr val="1A1A1A"/>
-                </a:solidFill>
-                <a:latin typeface="Noto Sans JP"/>
-                <a:ea typeface="Noto Sans JP"/>
-              </a:rPr>
-              <a:t>タンパク質構造の基礎</a:t>
-            </a:r>
-          </a:p>
-        </p:txBody>
-      </p:sp>
-      <p:sp>
-        <p:nvSpPr>
-          <p:cNvPr id="4" name="TextBox 3"/>
-          <p:cNvSpPr txBox="1"/>
-          <p:nvPr/>
-        </p:nvSpPr>
-        <p:spPr>
-          <a:xfrm>
-            <a:off x="594360" y="2971800"/>
-            <a:ext cx="5943600" cy="914400"/>
-          </a:xfrm>
-          <a:prstGeom prst="rect">
-            <a:avLst/>
-          </a:prstGeom>
-          <a:noFill/>
-        </p:spPr>
-        <p:txBody>
-          <a:bodyPr wrap="square" lIns="0" rIns="0" tIns="0" bIns="0" anchor="t">
-            <a:noAutofit/>
-          </a:bodyPr>
-          <a:lstStyle/>
-          <a:p>
-            <a:pPr algn="l">
-              <a:lnSpc>
-                <a:spcPct val="140000"/>
-              </a:lnSpc>
-            </a:pPr>
-            <a:r>
-              <a:rPr sz="2300" b="0" lang="ja-JP" altLang="en-US">
-                <a:solidFill>
-                  <a:srgbClr val="4D4D4D"/>
-                </a:solidFill>
-                <a:latin typeface="Noto Sans JP"/>
-                <a:ea typeface="Noto Sans JP"/>
-              </a:rPr>
-              <a:t>配列・相互作用・立体構造</a:t>
-            </a:r>
-          </a:p>
-        </p:txBody>
-      </p:sp>
-      <p:sp>
-        <p:nvSpPr>
-          <p:cNvPr id="5" name="TextBox 4"/>
-          <p:cNvSpPr txBox="1"/>
-          <p:nvPr/>
-        </p:nvSpPr>
-        <p:spPr>
-          <a:xfrm>
-            <a:off x="594360" y="5303520"/>
-            <a:ext cx="7315200" cy="502920"/>
-          </a:xfrm>
-          <a:prstGeom prst="rect">
-            <a:avLst/>
-          </a:prstGeom>
-          <a:noFill/>
-        </p:spPr>
-        <p:txBody>
-          <a:bodyPr wrap="square" lIns="0" rIns="0" tIns="0" bIns="0" anchor="t">
-            <a:noAutofit/>
-          </a:bodyPr>
-          <a:lstStyle/>
-          <a:p>
-            <a:pPr algn="l">
-              <a:lnSpc>
-                <a:spcPct val="140000"/>
-              </a:lnSpc>
-            </a:pPr>
-            <a:r>
-              <a:rPr sz="1700" b="0" lang="ja-JP" altLang="en-US">
+              <a:rPr sz="1100" b="0" lang="ja-JP" altLang="en-US">
                 <a:solidFill>
                   <a:srgbClr val="333333"/>
                 </a:solidFill>
                 <a:latin typeface="Noto Sans JP"/>
                 <a:ea typeface="Noto Sans JP"/>
               </a:rPr>
-              <a:t>松永 康佑　埼玉大学 大学院理工学研究科</a:t>
+              <a:t>図：ユビキチンのCα座標（PDB: 1UBQ）。配列順に色分け。</a:t>
             </a:r>
           </a:p>
         </p:txBody>
       </p:sp>
       <p:pic>
         <p:nvPicPr>
-          <p:cNvPr id="6" name="Picture 5" descr="logo: saitama"/>
+          <p:cNvPr id="9" name="Picture 8" descr="image.png"/>
           <p:cNvPicPr>
             <a:picLocks noChangeAspect="1"/>
           </p:cNvPicPr>
           <p:nvPr/>
         </p:nvPicPr>
         <p:blipFill>
-          <a:blip r:embed="rId3"/>
+          <a:blip r:embed="rId4"/>
+          <a:srcRect l="26948" r="19675" t="14545" b="20606"/>
           <a:stretch>
             <a:fillRect/>
           </a:stretch>
         </p:blipFill>
         <p:spPr>
           <a:xfrm>
-            <a:off x="10819809" y="5730259"/>
-            <a:ext cx="761980" cy="761980"/>
-          </a:xfrm>
-          <a:prstGeom prst="rect">
-            <a:avLst/>
-          </a:prstGeom>
-        </p:spPr>
-      </p:pic>
-      <p:pic>
-        <p:nvPicPr>
-          <p:cNvPr id="7" name="Picture 6" descr="trace.png"/>
-          <p:cNvPicPr>
-            <a:picLocks noChangeAspect="1"/>
-          </p:cNvPicPr>
-          <p:nvPr/>
-        </p:nvPicPr>
-        <p:blipFill>
-          <a:blip r:embed="rId4"/>
-          <a:srcRect l="26948" t="14545" r="19675" b="20606"/>
-          <a:stretch>
-            <a:fillRect/>
-          </a:stretch>
-        </p:blipFill>
-        <p:spPr>
-          <a:xfrm>
-            <a:off x="7623703" y="1417320"/>
-            <a:ext cx="3863553" cy="4023360"/>
+            <a:off x="6675120" y="960120"/>
+            <a:ext cx="4782312" cy="4983480"/>
           </a:xfrm>
           <a:prstGeom prst="rect">
             <a:avLst/>

</xml_diff>